<commit_message>
style: adjust spacing and table padding in presentation slides
</commit_message>
<xml_diff>
--- a/docs/presentation/file-3/slide-02-motivation.pptx
+++ b/docs/presentation/file-3/slide-02-motivation.pptx
@@ -10,8 +10,8 @@
   <p:notesMasterIdLst>
     <p:notesMasterId r:id="rId3"/>
   </p:notesMasterIdLst>
-  <p:sldSz cx="12191695" cy="6858000"/>
-  <p:notesSz cx="6858000" cy="12191695"/>
+  <p:sldSz cx="12192000" cy="6858000"/>
+  <p:notesSz cx="6858000" cy="12192000"/>
   <p:defaultTextStyle>
     <a:lvl1pPr marL="0" algn="l" defTabSz="914400" rtl="0" eaLnBrk="1" latinLnBrk="0" hangingPunct="1">
       <a:defRPr sz="1800" kern="1200">
@@ -854,6 +854,13 @@
 <file path=ppt/slides/slide1.xml><?xml version="1.0" encoding="utf-8"?>
 <p:sld xmlns:a="http://schemas.openxmlformats.org/drawingml/2006/main" xmlns:r="http://schemas.openxmlformats.org/officeDocument/2006/relationships" xmlns:p="http://schemas.openxmlformats.org/presentationml/2006/main">
   <p:cSld name="Slide 1">
+    <p:bg>
+      <p:bgPr>
+        <a:solidFill>
+          <a:srgbClr val="F7F4EF"/>
+        </a:solidFill>
+      </p:bgPr>
+    </p:bg>
     <p:spTree>
       <p:nvGrpSpPr>
         <p:cNvPr id="1" name=""/>
@@ -868,9 +875,353 @@
           <a:chExt cx="0" cy="0"/>
         </a:xfrm>
       </p:grpSpPr>
+      <p:sp>
+        <p:nvSpPr>
+          <p:cNvPr id="2" name="Text 0"/>
+          <p:cNvSpPr txBox="1"/>
+          <p:nvPr/>
+        </p:nvSpPr>
+        <p:spPr>
+          <a:xfrm>
+            <a:off x="8572500" y="228600"/>
+            <a:ext cx="2857500" cy="228600"/>
+          </a:xfrm>
+          <a:prstGeom prst="rect">
+            <a:avLst/>
+          </a:prstGeom>
+          <a:noFill/>
+          <a:ln/>
+        </p:spPr>
+        <p:txBody>
+          <a:bodyPr wrap="square" lIns="0" tIns="0" rIns="0" bIns="0" rtlCol="0" anchor="ctr"/>
+          <a:lstStyle/>
+          <a:p>
+            <a:pPr algn="r" indent="0" marL="0">
+              <a:buNone/>
+            </a:pPr>
+            <a:r>
+              <a:rPr lang="en-US" sz="1300" b="1" dirty="0">
+                <a:solidFill>
+                  <a:srgbClr val="8B1A1A"/>
+                </a:solidFill>
+                <a:latin typeface="Playfair Display" pitchFamily="34" charset="0"/>
+                <a:ea typeface="Playfair Display" pitchFamily="34" charset="-122"/>
+                <a:cs typeface="Playfair Display" pitchFamily="34" charset="-120"/>
+              </a:rPr>
+              <a:t>RedGrid</a:t>
+            </a:r>
+            <a:endParaRPr lang="en-US" sz="1300" dirty="0"/>
+          </a:p>
+        </p:txBody>
+      </p:sp>
+      <p:sp>
+        <p:nvSpPr>
+          <p:cNvPr id="3" name="Text 1"/>
+          <p:cNvSpPr txBox="1"/>
+          <p:nvPr/>
+        </p:nvSpPr>
+        <p:spPr>
+          <a:xfrm>
+            <a:off x="762000" y="571500"/>
+            <a:ext cx="10668000" cy="533400"/>
+          </a:xfrm>
+          <a:prstGeom prst="rect">
+            <a:avLst/>
+          </a:prstGeom>
+          <a:noFill/>
+          <a:ln/>
+        </p:spPr>
+        <p:txBody>
+          <a:bodyPr wrap="square" lIns="0" tIns="0" rIns="0" bIns="0" rtlCol="0" anchor="ctr"/>
+          <a:lstStyle/>
+          <a:p>
+            <a:pPr algn="l" indent="0" marL="0">
+              <a:buNone/>
+            </a:pPr>
+            <a:r>
+              <a:rPr lang="en-US" sz="3300" b="1" dirty="0">
+                <a:solidFill>
+                  <a:srgbClr val="1A1A2E"/>
+                </a:solidFill>
+                <a:latin typeface="Playfair Display" pitchFamily="34" charset="0"/>
+                <a:ea typeface="Playfair Display" pitchFamily="34" charset="-122"/>
+                <a:cs typeface="Playfair Display" pitchFamily="34" charset="-120"/>
+              </a:rPr>
+              <a:t>Why This Matters</a:t>
+            </a:r>
+            <a:endParaRPr lang="en-US" sz="3300" dirty="0"/>
+          </a:p>
+        </p:txBody>
+      </p:sp>
+      <p:sp>
+        <p:nvSpPr>
+          <p:cNvPr id="4" name="Shape 2"/>
+          <p:cNvSpPr/>
+          <p:nvPr/>
+        </p:nvSpPr>
+        <p:spPr>
+          <a:xfrm>
+            <a:off x="762000" y="1171575"/>
+            <a:ext cx="5867400" cy="28575"/>
+          </a:xfrm>
+          <a:prstGeom prst="rect">
+            <a:avLst/>
+          </a:prstGeom>
+          <a:solidFill>
+            <a:srgbClr val="8B1A1A"/>
+          </a:solidFill>
+          <a:ln/>
+        </p:spPr>
+      </p:sp>
+      <p:sp>
+        <p:nvSpPr>
+          <p:cNvPr id="5" name="Text 3"/>
+          <p:cNvSpPr txBox="1"/>
+          <p:nvPr/>
+        </p:nvSpPr>
+        <p:spPr>
+          <a:xfrm>
+            <a:off x="762000" y="1452563"/>
+            <a:ext cx="6187440" cy="171450"/>
+          </a:xfrm>
+          <a:prstGeom prst="rect">
+            <a:avLst/>
+          </a:prstGeom>
+          <a:noFill/>
+          <a:ln/>
+        </p:spPr>
+        <p:txBody>
+          <a:bodyPr wrap="square" lIns="0" tIns="0" rIns="0" bIns="0" rtlCol="0" anchor="ctr"/>
+          <a:lstStyle/>
+          <a:p>
+            <a:pPr indent="0" marL="0">
+              <a:buNone/>
+            </a:pPr>
+            <a:r>
+              <a:rPr lang="en-US" sz="950" b="1" spc="200" kern="0" dirty="0">
+                <a:solidFill>
+                  <a:srgbClr val="9A9AAA"/>
+                </a:solidFill>
+                <a:latin typeface="Source Sans 3" pitchFamily="34" charset="0"/>
+                <a:ea typeface="Source Sans 3" pitchFamily="34" charset="-122"/>
+                <a:cs typeface="Source Sans 3" pitchFamily="34" charset="-120"/>
+              </a:rPr>
+              <a:t>PROJECT MOTIVATION</a:t>
+            </a:r>
+            <a:endParaRPr lang="en-US" sz="950" dirty="0"/>
+          </a:p>
+        </p:txBody>
+      </p:sp>
+      <p:sp>
+        <p:nvSpPr>
+          <p:cNvPr id="6" name="Text 4"/>
+          <p:cNvSpPr txBox="1"/>
+          <p:nvPr/>
+        </p:nvSpPr>
+        <p:spPr>
+          <a:xfrm>
+            <a:off x="762000" y="1833563"/>
+            <a:ext cx="6187440" cy="1276350"/>
+          </a:xfrm>
+          <a:prstGeom prst="rect">
+            <a:avLst/>
+          </a:prstGeom>
+          <a:noFill/>
+          <a:ln/>
+        </p:spPr>
+        <p:txBody>
+          <a:bodyPr wrap="square" lIns="0" tIns="0" rIns="0" bIns="0" rtlCol="0" anchor="t"/>
+          <a:lstStyle/>
+          <a:p>
+            <a:pPr indent="0" marL="0">
+              <a:lnSpc>
+                <a:spcPct val="140000"/>
+              </a:lnSpc>
+              <a:buNone/>
+            </a:pPr>
+            <a:r>
+              <a:rPr lang="en-US" sz="2400" i="1" dirty="0">
+                <a:solidFill>
+                  <a:srgbClr val="1A1A2E"/>
+                </a:solidFill>
+                <a:latin typeface="Playfair Display" pitchFamily="34" charset="0"/>
+                <a:ea typeface="Playfair Display" pitchFamily="34" charset="-122"/>
+                <a:cs typeface="Playfair Display" pitchFamily="34" charset="-120"/>
+              </a:rPr>
+              <a:t>“Attackers move fast. Defenders move slow. Automated testers don’t move at all.”</a:t>
+            </a:r>
+            <a:endParaRPr lang="en-US" sz="2400" dirty="0"/>
+          </a:p>
+        </p:txBody>
+      </p:sp>
+      <p:sp>
+        <p:nvSpPr>
+          <p:cNvPr id="7" name="Text 5"/>
+          <p:cNvSpPr txBox="1"/>
+          <p:nvPr/>
+        </p:nvSpPr>
+        <p:spPr>
+          <a:xfrm>
+            <a:off x="762000" y="3338513"/>
+            <a:ext cx="6187440" cy="1219200"/>
+          </a:xfrm>
+          <a:prstGeom prst="rect">
+            <a:avLst/>
+          </a:prstGeom>
+          <a:noFill/>
+          <a:ln/>
+        </p:spPr>
+        <p:txBody>
+          <a:bodyPr wrap="square" lIns="0" tIns="0" rIns="0" bIns="0" rtlCol="0" anchor="t"/>
+          <a:lstStyle/>
+          <a:p>
+            <a:pPr indent="0" marL="0">
+              <a:lnSpc>
+                <a:spcPct val="160000"/>
+              </a:lnSpc>
+              <a:buNone/>
+            </a:pPr>
+            <a:r>
+              <a:rPr lang="en-US" sz="1500" dirty="0">
+                <a:solidFill>
+                  <a:srgbClr val="1A1A2E"/>
+                </a:solidFill>
+                <a:latin typeface="Source Sans 3" pitchFamily="34" charset="0"/>
+                <a:ea typeface="Source Sans 3" pitchFamily="34" charset="-122"/>
+                <a:cs typeface="Source Sans 3" pitchFamily="34" charset="-120"/>
+              </a:rPr>
+              <a:t>Security vulnerabilities are found daily in web apps, APIs, and networks. Human pen testers are scarce and expensive. Automated scanners use fixed rule-sets — they cannot reason, adapt, or chain exploits.</a:t>
+            </a:r>
+            <a:endParaRPr lang="en-US" sz="1500" dirty="0"/>
+          </a:p>
+        </p:txBody>
+      </p:sp>
+      <p:sp>
+        <p:nvSpPr>
+          <p:cNvPr id="8" name="Shape 6"/>
+          <p:cNvSpPr/>
+          <p:nvPr/>
+        </p:nvSpPr>
+        <p:spPr>
+          <a:xfrm>
+            <a:off x="762000" y="4786313"/>
+            <a:ext cx="6187440" cy="1343025"/>
+          </a:xfrm>
+          <a:prstGeom prst="rect">
+            <a:avLst>
+              <a:gd name="adj" fmla="val 2837"/>
+            </a:avLst>
+          </a:prstGeom>
+          <a:solidFill>
+            <a:srgbClr val="F2EAD9"/>
+          </a:solidFill>
+          <a:ln/>
+        </p:spPr>
+      </p:sp>
+      <p:sp>
+        <p:nvSpPr>
+          <p:cNvPr id="9" name="Shape 7"/>
+          <p:cNvSpPr/>
+          <p:nvPr/>
+        </p:nvSpPr>
+        <p:spPr>
+          <a:xfrm>
+            <a:off x="762000" y="4786313"/>
+            <a:ext cx="38100" cy="1343025"/>
+          </a:xfrm>
+          <a:prstGeom prst="rect">
+            <a:avLst/>
+          </a:prstGeom>
+          <a:solidFill>
+            <a:srgbClr val="A0631A"/>
+          </a:solidFill>
+          <a:ln/>
+        </p:spPr>
+      </p:sp>
+      <p:sp>
+        <p:nvSpPr>
+          <p:cNvPr id="10" name="Text 8"/>
+          <p:cNvSpPr txBox="1"/>
+          <p:nvPr/>
+        </p:nvSpPr>
+        <p:spPr>
+          <a:xfrm>
+            <a:off x="1028700" y="4976813"/>
+            <a:ext cx="5654040" cy="228600"/>
+          </a:xfrm>
+          <a:prstGeom prst="rect">
+            <a:avLst/>
+          </a:prstGeom>
+          <a:noFill/>
+          <a:ln/>
+        </p:spPr>
+        <p:txBody>
+          <a:bodyPr wrap="square" lIns="0" tIns="0" rIns="0" bIns="0" rtlCol="0" anchor="ctr"/>
+          <a:lstStyle/>
+          <a:p>
+            <a:pPr indent="0" marL="0">
+              <a:buNone/>
+            </a:pPr>
+            <a:r>
+              <a:rPr lang="en-US" sz="1350" b="1" dirty="0">
+                <a:solidFill>
+                  <a:srgbClr val="7A4F1A"/>
+                </a:solidFill>
+                <a:latin typeface="Source Sans 3" pitchFamily="34" charset="0"/>
+                <a:ea typeface="Source Sans 3" pitchFamily="34" charset="-122"/>
+                <a:cs typeface="Source Sans 3" pitchFamily="34" charset="-120"/>
+              </a:rPr>
+              <a:t>The question:</a:t>
+            </a:r>
+            <a:endParaRPr lang="en-US" sz="1350" dirty="0"/>
+          </a:p>
+        </p:txBody>
+      </p:sp>
+      <p:sp>
+        <p:nvSpPr>
+          <p:cNvPr id="11" name="Text 9"/>
+          <p:cNvSpPr txBox="1"/>
+          <p:nvPr/>
+        </p:nvSpPr>
+        <p:spPr>
+          <a:xfrm>
+            <a:off x="1028700" y="5205413"/>
+            <a:ext cx="5654040" cy="809625"/>
+          </a:xfrm>
+          <a:prstGeom prst="rect">
+            <a:avLst/>
+          </a:prstGeom>
+          <a:noFill/>
+          <a:ln/>
+        </p:spPr>
+        <p:txBody>
+          <a:bodyPr wrap="square" lIns="0" tIns="0" rIns="0" bIns="0" rtlCol="0" anchor="t"/>
+          <a:lstStyle/>
+          <a:p>
+            <a:pPr indent="0" marL="0">
+              <a:lnSpc>
+                <a:spcPct val="150000"/>
+              </a:lnSpc>
+              <a:buNone/>
+            </a:pPr>
+            <a:r>
+              <a:rPr lang="en-US" sz="1575" dirty="0">
+                <a:solidFill>
+                  <a:srgbClr val="1A1A2E"/>
+                </a:solidFill>
+                <a:latin typeface="Source Sans 3" pitchFamily="34" charset="0"/>
+                <a:ea typeface="Source Sans 3" pitchFamily="34" charset="-122"/>
+                <a:cs typeface="Source Sans 3" pitchFamily="34" charset="-120"/>
+              </a:rPr>
+              <a:t>Can an LLM agent carry out penetration testing autonomously — without step-by-step human direction?</a:t>
+            </a:r>
+            <a:endParaRPr lang="en-US" sz="1575" dirty="0"/>
+          </a:p>
+        </p:txBody>
+      </p:sp>
       <p:pic>
         <p:nvPicPr>
-          <p:cNvPr id="2" name="Image 0" descr="slide02.png">    </p:cNvPr>
+          <p:cNvPr id="12" name="Image 0" descr="graph.png">    </p:cNvPr>
           <p:cNvPicPr>
             <a:picLocks noChangeAspect="1"/>
           </p:cNvPicPr>
@@ -884,14 +1235,159 @@
         </p:blipFill>
         <p:spPr>
           <a:xfrm>
-            <a:off x="0" y="0"/>
-            <a:ext cx="12191695" cy="6858000"/>
+            <a:off x="7330440" y="1919288"/>
+            <a:ext cx="4099560" cy="3429000"/>
           </a:xfrm>
           <a:prstGeom prst="rect">
             <a:avLst/>
           </a:prstGeom>
         </p:spPr>
       </p:pic>
+      <p:sp>
+        <p:nvSpPr>
+          <p:cNvPr id="13" name="Shape 10"/>
+          <p:cNvSpPr/>
+          <p:nvPr/>
+        </p:nvSpPr>
+        <p:spPr>
+          <a:xfrm>
+            <a:off x="7330440" y="1919288"/>
+            <a:ext cx="4099560" cy="3429000"/>
+          </a:xfrm>
+          <a:prstGeom prst="roundRect">
+            <a:avLst>
+              <a:gd name="adj" fmla="val 1111"/>
+            </a:avLst>
+          </a:prstGeom>
+          <a:ln w="9525">
+            <a:solidFill>
+              <a:srgbClr val="D4CFC8"/>
+            </a:solidFill>
+            <a:prstDash val="solid"/>
+          </a:ln>
+        </p:spPr>
+      </p:sp>
+      <p:sp>
+        <p:nvSpPr>
+          <p:cNvPr id="14" name="Text 11"/>
+          <p:cNvSpPr txBox="1"/>
+          <p:nvPr/>
+        </p:nvSpPr>
+        <p:spPr>
+          <a:xfrm>
+            <a:off x="7330440" y="5500688"/>
+            <a:ext cx="4099560" cy="161925"/>
+          </a:xfrm>
+          <a:prstGeom prst="rect">
+            <a:avLst/>
+          </a:prstGeom>
+          <a:noFill/>
+          <a:ln/>
+        </p:spPr>
+        <p:txBody>
+          <a:bodyPr wrap="square" lIns="0" tIns="0" rIns="0" bIns="0" rtlCol="0" anchor="ctr"/>
+          <a:lstStyle/>
+          <a:p>
+            <a:pPr algn="ctr" indent="0" marL="0">
+              <a:buNone/>
+            </a:pPr>
+            <a:r>
+              <a:rPr lang="en-US" sz="975" b="1" spc="150" kern="0" dirty="0">
+                <a:solidFill>
+                  <a:srgbClr val="9A9AAA"/>
+                </a:solidFill>
+                <a:latin typeface="Source Sans 3" pitchFamily="34" charset="0"/>
+                <a:ea typeface="Source Sans 3" pitchFamily="34" charset="-122"/>
+                <a:cs typeface="Source Sans 3" pitchFamily="34" charset="-120"/>
+              </a:rPr>
+              <a:t>ATTACK SURFACE EXPLORATION</a:t>
+            </a:r>
+            <a:endParaRPr lang="en-US" sz="975" dirty="0"/>
+          </a:p>
+        </p:txBody>
+      </p:sp>
+      <p:sp>
+        <p:nvSpPr>
+          <p:cNvPr id="15" name="Shape 12"/>
+          <p:cNvSpPr/>
+          <p:nvPr/>
+        </p:nvSpPr>
+        <p:spPr>
+          <a:xfrm>
+            <a:off x="0" y="6515100"/>
+            <a:ext cx="12192000" cy="0"/>
+          </a:xfrm>
+          <a:prstGeom prst="line">
+            <a:avLst/>
+          </a:prstGeom>
+          <a:noFill/>
+          <a:ln w="9525">
+            <a:solidFill>
+              <a:srgbClr val="D4CFC8"/>
+            </a:solidFill>
+            <a:prstDash val="solid"/>
+          </a:ln>
+        </p:spPr>
+      </p:sp>
+      <p:sp>
+        <p:nvSpPr>
+          <p:cNvPr id="16" name="Text 13"/>
+          <p:cNvSpPr txBox="1"/>
+          <p:nvPr/>
+        </p:nvSpPr>
+        <p:spPr>
+          <a:xfrm>
+            <a:off x="10287000" y="6610350"/>
+            <a:ext cx="1143000" cy="171450"/>
+          </a:xfrm>
+          <a:prstGeom prst="rect">
+            <a:avLst/>
+          </a:prstGeom>
+          <a:noFill/>
+          <a:ln/>
+        </p:spPr>
+        <p:txBody>
+          <a:bodyPr wrap="square" lIns="0" tIns="0" rIns="0" bIns="0" rtlCol="0" anchor="ctr"/>
+          <a:lstStyle/>
+          <a:p>
+            <a:pPr algn="r" indent="0" marL="0">
+              <a:buNone/>
+            </a:pPr>
+            <a:r>
+              <a:rPr lang="en-US" sz="975" dirty="0">
+                <a:solidFill>
+                  <a:srgbClr val="9A9AAA"/>
+                </a:solidFill>
+                <a:latin typeface="IBM Plex Mono" pitchFamily="34" charset="0"/>
+                <a:ea typeface="IBM Plex Mono" pitchFamily="34" charset="-122"/>
+                <a:cs typeface="IBM Plex Mono" pitchFamily="34" charset="-120"/>
+              </a:rPr>
+              <a:t>02 / 20</a:t>
+            </a:r>
+            <a:endParaRPr lang="en-US" sz="975" dirty="0"/>
+          </a:p>
+        </p:txBody>
+      </p:sp>
+      <p:sp>
+        <p:nvSpPr>
+          <p:cNvPr id="17" name="Shape 14"/>
+          <p:cNvSpPr/>
+          <p:nvPr/>
+        </p:nvSpPr>
+        <p:spPr>
+          <a:xfrm>
+            <a:off x="0" y="6829425"/>
+            <a:ext cx="609600" cy="28575"/>
+          </a:xfrm>
+          <a:prstGeom prst="rect">
+            <a:avLst/>
+          </a:prstGeom>
+          <a:solidFill>
+            <a:srgbClr val="8B1A1A"/>
+          </a:solidFill>
+          <a:ln/>
+        </p:spPr>
+      </p:sp>
     </p:spTree>
   </p:cSld>
   <p:clrMapOvr>

</xml_diff>